<commit_message>
fix: add aiosqlite and python version for Render deployment, remove gemini, and configure Vercel API url
</commit_message>
<xml_diff>
--- a/CIVICPULSE-BRICS.pptx
+++ b/CIVICPULSE-BRICS.pptx
@@ -5527,11 +5527,11 @@
               </a:defRPr>
             </a:pPr>
             <a:r>
-              <a:t>GEMINI 2.5</a:t>
+              <a:t>MULTILINGUAL</a:t>
             </a:r>
             <a:br/>
             <a:r>
-              <a:t>FLASH</a:t>
+              <a:t>NLU</a:t>
             </a:r>
           </a:p>
         </p:txBody>
@@ -6220,7 +6220,7 @@
               </a:defRPr>
             </a:pPr>
             <a:r>
-              <a:t>Gemini 2.5 Flash API  +  Scikit-Learn DBSCAN  +  Haversine Matrix  +  Zero-Setup SQLite / PostgreSQL</a:t>
+              <a:t>Multilingual Transformer NLU  +  Scikit-Learn DBSCAN  +  Haversine Matrix  +  Zero-Setup SQLite / PostgreSQL</a:t>
             </a:r>
           </a:p>
         </p:txBody>
@@ -7410,7 +7410,7 @@
               </a:defRPr>
             </a:pPr>
             <a:r>
-              <a:t>Gemini 2.5 Flash · Multilingual NLU &amp; Generative Project Solutions</a:t>
+              <a:t>Multilingual NLU Engine · Dialect Synthesis &amp; Project Solutions</a:t>
             </a:r>
           </a:p>
         </p:txBody>

</xml_diff>